<commit_message>
Move prototype area upward and widen slide four architecture
</commit_message>
<xml_diff>
--- a/downloads/presentation/revision-2/ThirdEye-content-draft.pptx
+++ b/downloads/presentation/revision-2/ThirdEye-content-draft.pptx
@@ -1217,7 +1217,7 @@
           <a:p/>
           <a:p>
             <a:r>
-              <a:t>왼쪽은 시스템 구성이고 오른쪽은 이 구성에 따라 직접 연결한 테스트용 프로토타입입니다. VL53L8CX 두 개와 XIAO ESP32-S3 Sense를 점퍼선으로 연결했습니다. ESP32는 거리와 카메라 영상을 USB로 보내고 휴대폰이 객체 인식과 소리 합성을 담당합니다. 이 사진은 최종 안경 형태가 아니라 기능을 검증하기 위해 제작한 구조입니다. 다음 장에서는 이 프로토타입에서 Y형 점퍼선을 사용해 두 센서가 배선을 공유하면서도 각각의 측정값을 구분하는 방법을 설명하겠습니다.</a:t>
+              <a:t>위쪽 사진은 아래의 구성에 따라 직접 연결한 테스트용 프로토타입입니다. VL53L8CX 두 개와 XIAO ESP32-S3 Sense를 점퍼선으로 연결했습니다. ESP32는 거리와 카메라 영상을 USB로 보내고 휴대폰이 객체 인식과 소리 합성을 담당합니다. 그 결과를 스테레오 이어폰으로 전달합니다. 이 사진은 최종 안경 형태가 아니라 기능을 검증하기 위해 제작한 구조입니다. 다음 장에서는 이 프로토타입에서 Y형 점퍼선을 사용해 두 센서가 배선을 공유하면서도 각각의 측정값을 구분하는 방법을 설명하겠습니다.</a:t>
             </a:r>
           </a:p>
           <a:p/>
@@ -1228,7 +1228,7 @@
           </a:p>
           <a:p>
             <a:r>
-              <a:t>사진 1: 사용자가 보낸 실제 테스트 프로토타입. 물품 구매·납땜·프로토타입 제작 완료는 사용자의 이번 진행 상황 확인을 반영.</a:t>
+              <a:t>사용자 배치 수정 요청 반영: 사진 영역을 기존 y=210에서 y=181로 올리고 아키텍처를 슬라이드 아래 전체 가로 폭으로 확장. 사진 1 원본 파일은 수신 대기이며 현재는 사진 자리 표시자가 표시됨.</a:t>
             </a:r>
           </a:p>
         </p:txBody>
@@ -18912,12 +18912,12 @@
         </p:nvSpPr>
         <p:spPr>
           <a:xfrm>
-            <a:off x="711200" y="2857500"/>
-            <a:ext cx="1536700" cy="774700"/>
+            <a:off x="7302500" y="2298700"/>
+            <a:ext cx="4178300" cy="2095499"/>
           </a:xfrm>
           <a:prstGeom prst="roundRect">
             <a:avLst>
-              <a:gd name="adj" fmla="val 13114"/>
+              <a:gd name="adj" fmla="val 4848"/>
             </a:avLst>
           </a:prstGeom>
           <a:solidFill>
@@ -18959,8 +18959,8 @@
         </p:nvSpPr>
         <p:spPr>
           <a:xfrm>
-            <a:off x="838200" y="3009900"/>
-            <a:ext cx="1282700" cy="304800"/>
+            <a:off x="7505700" y="2990850"/>
+            <a:ext cx="3771900" cy="368300"/>
           </a:xfrm>
           <a:prstGeom prst="rect">
             <a:avLst/>
@@ -18973,7 +18973,7 @@
           </a:bodyPr>
           <a:lstStyle/>
           <a:p>
-            <a:pPr>
+            <a:pPr algn="ctr">
               <a:lnSpc>
                 <a:spcPct val="118000"/>
               </a:lnSpc>
@@ -18983,55 +18983,7 @@
               <a:spcAft>
                 <a:spcPts val="0"/>
               </a:spcAft>
-              <a:defRPr sz="1300" b="1">
-                <a:solidFill>
-                  <a:srgbClr val="FFFFFF"/>
-                </a:solidFill>
-                <a:latin typeface="Noto Sans CJK KR"/>
-              </a:defRPr>
-            </a:pPr>
-            <a:r>
-              <a:rPr>
-                <a:ea typeface="Noto Sans CJK KR"/>
-              </a:rPr>
-              <a:t>A · 왼쪽 L8</a:t>
-            </a:r>
-          </a:p>
-        </p:txBody>
-      </p:sp>
-      <p:sp>
-        <p:nvSpPr>
-          <p:cNvPr id="9" name="TextBox 8"/>
-          <p:cNvSpPr txBox="1"/>
-          <p:nvPr/>
-        </p:nvSpPr>
-        <p:spPr>
-          <a:xfrm>
-            <a:off x="838200" y="3340100"/>
-            <a:ext cx="1282700" cy="254000"/>
-          </a:xfrm>
-          <a:prstGeom prst="rect">
-            <a:avLst/>
-          </a:prstGeom>
-          <a:noFill/>
-        </p:spPr>
-        <p:txBody>
-          <a:bodyPr wrap="square" lIns="0" rIns="0" tIns="0" bIns="0">
-            <a:spAutoFit/>
-          </a:bodyPr>
-          <a:lstStyle/>
-          <a:p>
-            <a:pPr>
-              <a:lnSpc>
-                <a:spcPct val="118000"/>
-              </a:lnSpc>
-              <a:spcBef>
-                <a:spcPts val="0"/>
-              </a:spcBef>
-              <a:spcAft>
-                <a:spcPts val="0"/>
-              </a:spcAft>
-              <a:defRPr sz="1000" b="0">
+              <a:defRPr sz="1600" b="1">
                 <a:solidFill>
                   <a:srgbClr val="ACBBB9"/>
                 </a:solidFill>
@@ -19042,68 +18994,21 @@
               <a:rPr>
                 <a:ea typeface="Noto Sans CJK KR"/>
               </a:rPr>
-              <a:t>8×8 ToF 센서</a:t>
+              <a:t>사진 1 · 테스트용 프로토타입</a:t>
             </a:r>
           </a:p>
         </p:txBody>
       </p:sp>
       <p:sp>
         <p:nvSpPr>
-          <p:cNvPr id="10" name="Rounded Rectangle 9"/>
-          <p:cNvSpPr/>
-          <p:nvPr/>
-        </p:nvSpPr>
-        <p:spPr>
-          <a:xfrm>
-            <a:off x="711200" y="3987799"/>
-            <a:ext cx="1536700" cy="774700"/>
-          </a:xfrm>
-          <a:prstGeom prst="roundRect">
-            <a:avLst>
-              <a:gd name="adj" fmla="val 13114"/>
-            </a:avLst>
-          </a:prstGeom>
-          <a:solidFill>
-            <a:srgbClr val="202B30"/>
-          </a:solidFill>
-          <a:ln w="8890">
-            <a:solidFill>
-              <a:srgbClr val="3A474B"/>
-            </a:solidFill>
-          </a:ln>
-        </p:spPr>
-        <p:style>
-          <a:lnRef idx="1">
-            <a:schemeClr val="accent1"/>
-          </a:lnRef>
-          <a:fillRef idx="3">
-            <a:schemeClr val="accent1"/>
-          </a:fillRef>
-          <a:effectRef idx="2">
-            <a:schemeClr val="accent1"/>
-          </a:effectRef>
-          <a:fontRef idx="minor">
-            <a:schemeClr val="lt1"/>
-          </a:fontRef>
-        </p:style>
-        <p:txBody>
-          <a:bodyPr rtlCol="0" anchor="ctr"/>
-          <a:lstStyle/>
-          <a:p>
-            <a:pPr algn="ctr"/>
-          </a:p>
-        </p:txBody>
-      </p:sp>
-      <p:sp>
-        <p:nvSpPr>
-          <p:cNvPr id="11" name="TextBox 10"/>
+          <p:cNvPr id="9" name="TextBox 8"/>
           <p:cNvSpPr txBox="1"/>
           <p:nvPr/>
         </p:nvSpPr>
         <p:spPr>
           <a:xfrm>
-            <a:off x="838200" y="4140200"/>
-            <a:ext cx="1282700" cy="304800"/>
+            <a:off x="7505700" y="3486150"/>
+            <a:ext cx="3771900" cy="381000"/>
           </a:xfrm>
           <a:prstGeom prst="rect">
             <a:avLst/>
@@ -19116,7 +19021,7 @@
           </a:bodyPr>
           <a:lstStyle/>
           <a:p>
-            <a:pPr>
+            <a:pPr algn="ctr">
               <a:lnSpc>
                 <a:spcPct val="118000"/>
               </a:lnSpc>
@@ -19126,55 +19031,7 @@
               <a:spcAft>
                 <a:spcPts val="0"/>
               </a:spcAft>
-              <a:defRPr sz="1300" b="1">
-                <a:solidFill>
-                  <a:srgbClr val="FFFFFF"/>
-                </a:solidFill>
-                <a:latin typeface="Noto Sans CJK KR"/>
-              </a:defRPr>
-            </a:pPr>
-            <a:r>
-              <a:rPr>
-                <a:ea typeface="Noto Sans CJK KR"/>
-              </a:rPr>
-              <a:t>B · 오른쪽 L8</a:t>
-            </a:r>
-          </a:p>
-        </p:txBody>
-      </p:sp>
-      <p:sp>
-        <p:nvSpPr>
-          <p:cNvPr id="12" name="TextBox 11"/>
-          <p:cNvSpPr txBox="1"/>
-          <p:nvPr/>
-        </p:nvSpPr>
-        <p:spPr>
-          <a:xfrm>
-            <a:off x="838200" y="4470400"/>
-            <a:ext cx="1282700" cy="254000"/>
-          </a:xfrm>
-          <a:prstGeom prst="rect">
-            <a:avLst/>
-          </a:prstGeom>
-          <a:noFill/>
-        </p:spPr>
-        <p:txBody>
-          <a:bodyPr wrap="square" lIns="0" rIns="0" tIns="0" bIns="0">
-            <a:spAutoFit/>
-          </a:bodyPr>
-          <a:lstStyle/>
-          <a:p>
-            <a:pPr>
-              <a:lnSpc>
-                <a:spcPct val="118000"/>
-              </a:lnSpc>
-              <a:spcBef>
-                <a:spcPts val="0"/>
-              </a:spcBef>
-              <a:spcAft>
-                <a:spcPts val="0"/>
-              </a:spcAft>
-              <a:defRPr sz="1000" b="0">
+              <a:defRPr sz="1200" b="0">
                 <a:solidFill>
                   <a:srgbClr val="ACBBB9"/>
                 </a:solidFill>
@@ -19185,507 +19042,21 @@
               <a:rPr>
                 <a:ea typeface="Noto Sans CJK KR"/>
               </a:rPr>
-              <a:t>8×8 ToF 센서</a:t>
+              <a:t>원본 파일 수신 후 삽입</a:t>
             </a:r>
           </a:p>
         </p:txBody>
       </p:sp>
-      <p:cxnSp>
-        <p:nvCxnSpPr>
-          <p:cNvPr id="13" name="Connector 12"/>
-          <p:cNvCxnSpPr/>
-          <p:nvPr/>
-        </p:nvCxnSpPr>
-        <p:spPr>
-          <a:xfrm>
-            <a:off x="2247900" y="3238500"/>
-            <a:ext cx="190500" cy="0"/>
-          </a:xfrm>
-          <a:prstGeom prst="line">
-            <a:avLst/>
-          </a:prstGeom>
-          <a:ln w="20320">
-            <a:solidFill>
-              <a:srgbClr val="287F89"/>
-            </a:solidFill>
-          </a:ln>
-        </p:spPr>
-        <p:style>
-          <a:lnRef idx="2">
-            <a:schemeClr val="accent1"/>
-          </a:lnRef>
-          <a:fillRef idx="0">
-            <a:schemeClr val="accent1"/>
-          </a:fillRef>
-          <a:effectRef idx="1">
-            <a:schemeClr val="accent1"/>
-          </a:effectRef>
-          <a:fontRef idx="minor">
-            <a:schemeClr val="tx1"/>
-          </a:fontRef>
-        </p:style>
-      </p:cxnSp>
-      <p:cxnSp>
-        <p:nvCxnSpPr>
-          <p:cNvPr id="14" name="Connector 13"/>
-          <p:cNvCxnSpPr/>
-          <p:nvPr/>
-        </p:nvCxnSpPr>
-        <p:spPr>
-          <a:xfrm>
-            <a:off x="2247900" y="4381500"/>
-            <a:ext cx="190500" cy="0"/>
-          </a:xfrm>
-          <a:prstGeom prst="line">
-            <a:avLst/>
-          </a:prstGeom>
-          <a:ln w="20320">
-            <a:solidFill>
-              <a:srgbClr val="287F89"/>
-            </a:solidFill>
-          </a:ln>
-        </p:spPr>
-        <p:style>
-          <a:lnRef idx="2">
-            <a:schemeClr val="accent1"/>
-          </a:lnRef>
-          <a:fillRef idx="0">
-            <a:schemeClr val="accent1"/>
-          </a:fillRef>
-          <a:effectRef idx="1">
-            <a:schemeClr val="accent1"/>
-          </a:effectRef>
-          <a:fontRef idx="minor">
-            <a:schemeClr val="tx1"/>
-          </a:fontRef>
-        </p:style>
-      </p:cxnSp>
-      <p:cxnSp>
-        <p:nvCxnSpPr>
-          <p:cNvPr id="15" name="Connector 14"/>
-          <p:cNvCxnSpPr/>
-          <p:nvPr/>
-        </p:nvCxnSpPr>
-        <p:spPr>
-          <a:xfrm>
-            <a:off x="2438400" y="3238500"/>
-            <a:ext cx="0" cy="1143000"/>
-          </a:xfrm>
-          <a:prstGeom prst="line">
-            <a:avLst/>
-          </a:prstGeom>
-          <a:ln w="20320">
-            <a:solidFill>
-              <a:srgbClr val="287F89"/>
-            </a:solidFill>
-          </a:ln>
-        </p:spPr>
-        <p:style>
-          <a:lnRef idx="2">
-            <a:schemeClr val="accent1"/>
-          </a:lnRef>
-          <a:fillRef idx="0">
-            <a:schemeClr val="accent1"/>
-          </a:fillRef>
-          <a:effectRef idx="1">
-            <a:schemeClr val="accent1"/>
-          </a:effectRef>
-          <a:fontRef idx="minor">
-            <a:schemeClr val="tx1"/>
-          </a:fontRef>
-        </p:style>
-      </p:cxnSp>
-      <p:cxnSp>
-        <p:nvCxnSpPr>
-          <p:cNvPr id="16" name="Connector 15"/>
-          <p:cNvCxnSpPr/>
-          <p:nvPr/>
-        </p:nvCxnSpPr>
-        <p:spPr>
-          <a:xfrm>
-            <a:off x="2438400" y="3797300"/>
-            <a:ext cx="228600" cy="0"/>
-          </a:xfrm>
-          <a:prstGeom prst="line">
-            <a:avLst/>
-          </a:prstGeom>
-          <a:ln w="20320">
-            <a:solidFill>
-              <a:srgbClr val="287F89"/>
-            </a:solidFill>
-            <a:tailEnd type="triangle"/>
-          </a:ln>
-        </p:spPr>
-        <p:style>
-          <a:lnRef idx="2">
-            <a:schemeClr val="accent1"/>
-          </a:lnRef>
-          <a:fillRef idx="0">
-            <a:schemeClr val="accent1"/>
-          </a:fillRef>
-          <a:effectRef idx="1">
-            <a:schemeClr val="accent1"/>
-          </a:effectRef>
-          <a:fontRef idx="minor">
-            <a:schemeClr val="tx1"/>
-          </a:fontRef>
-        </p:style>
-      </p:cxnSp>
-      <p:sp>
-        <p:nvSpPr>
-          <p:cNvPr id="17" name="Rounded Rectangle 16"/>
+      <p:sp>
+        <p:nvSpPr>
+          <p:cNvPr id="10" name="Rounded Rectangle 9"/>
           <p:cNvSpPr/>
           <p:nvPr/>
         </p:nvSpPr>
         <p:spPr>
           <a:xfrm>
-            <a:off x="2705100" y="3289300"/>
-            <a:ext cx="1498600" cy="1066800"/>
-          </a:xfrm>
-          <a:prstGeom prst="roundRect">
-            <a:avLst>
-              <a:gd name="adj" fmla="val 9523"/>
-            </a:avLst>
-          </a:prstGeom>
-          <a:solidFill>
-            <a:srgbClr val="202B30"/>
-          </a:solidFill>
-          <a:ln w="8890">
-            <a:solidFill>
-              <a:srgbClr val="3A474B"/>
-            </a:solidFill>
-          </a:ln>
-        </p:spPr>
-        <p:style>
-          <a:lnRef idx="1">
-            <a:schemeClr val="accent1"/>
-          </a:lnRef>
-          <a:fillRef idx="3">
-            <a:schemeClr val="accent1"/>
-          </a:fillRef>
-          <a:effectRef idx="2">
-            <a:schemeClr val="accent1"/>
-          </a:effectRef>
-          <a:fontRef idx="minor">
-            <a:schemeClr val="lt1"/>
-          </a:fontRef>
-        </p:style>
-        <p:txBody>
-          <a:bodyPr rtlCol="0" anchor="ctr"/>
-          <a:lstStyle/>
-          <a:p>
-            <a:pPr algn="ctr"/>
-          </a:p>
-        </p:txBody>
-      </p:sp>
-      <p:sp>
-        <p:nvSpPr>
-          <p:cNvPr id="18" name="TextBox 17"/>
-          <p:cNvSpPr txBox="1"/>
-          <p:nvPr/>
-        </p:nvSpPr>
-        <p:spPr>
-          <a:xfrm>
-            <a:off x="2857500" y="3479800"/>
-            <a:ext cx="1193800" cy="596900"/>
-          </a:xfrm>
-          <a:prstGeom prst="rect">
-            <a:avLst/>
-          </a:prstGeom>
-          <a:noFill/>
-        </p:spPr>
-        <p:txBody>
-          <a:bodyPr wrap="square" lIns="0" rIns="0" tIns="0" bIns="0">
-            <a:spAutoFit/>
-          </a:bodyPr>
-          <a:lstStyle/>
-          <a:p>
-            <a:pPr>
-              <a:lnSpc>
-                <a:spcPct val="118000"/>
-              </a:lnSpc>
-              <a:spcBef>
-                <a:spcPts val="0"/>
-              </a:spcBef>
-              <a:spcAft>
-                <a:spcPts val="0"/>
-              </a:spcAft>
-              <a:defRPr sz="1600" b="1">
-                <a:solidFill>
-                  <a:srgbClr val="FFFFFF"/>
-                </a:solidFill>
-                <a:latin typeface="Noto Sans CJK KR"/>
-              </a:defRPr>
-            </a:pPr>
-            <a:r>
-              <a:rPr>
-                <a:ea typeface="Noto Sans CJK KR"/>
-              </a:rPr>
-              <a:t>XIAO</a:t>
-            </a:r>
-          </a:p>
-          <a:p>
-            <a:pPr>
-              <a:lnSpc>
-                <a:spcPct val="118000"/>
-              </a:lnSpc>
-              <a:spcBef>
-                <a:spcPts val="0"/>
-              </a:spcBef>
-              <a:spcAft>
-                <a:spcPts val="0"/>
-              </a:spcAft>
-              <a:defRPr sz="1600" b="1">
-                <a:solidFill>
-                  <a:srgbClr val="FFFFFF"/>
-                </a:solidFill>
-                <a:latin typeface="Noto Sans CJK KR"/>
-              </a:defRPr>
-            </a:pPr>
-            <a:r>
-              <a:rPr>
-                <a:ea typeface="Noto Sans CJK KR"/>
-              </a:rPr>
-              <a:t>ESP32-S3</a:t>
-            </a:r>
-          </a:p>
-        </p:txBody>
-      </p:sp>
-      <p:cxnSp>
-        <p:nvCxnSpPr>
-          <p:cNvPr id="19" name="Connector 18"/>
-          <p:cNvCxnSpPr/>
-          <p:nvPr/>
-        </p:nvCxnSpPr>
-        <p:spPr>
-          <a:xfrm>
-            <a:off x="4203700" y="3797300"/>
-            <a:ext cx="292100" cy="0"/>
-          </a:xfrm>
-          <a:prstGeom prst="line">
-            <a:avLst/>
-          </a:prstGeom>
-          <a:ln w="20320">
-            <a:solidFill>
-              <a:srgbClr val="287F89"/>
-            </a:solidFill>
-            <a:tailEnd type="triangle"/>
-          </a:ln>
-        </p:spPr>
-        <p:style>
-          <a:lnRef idx="2">
-            <a:schemeClr val="accent1"/>
-          </a:lnRef>
-          <a:fillRef idx="0">
-            <a:schemeClr val="accent1"/>
-          </a:fillRef>
-          <a:effectRef idx="1">
-            <a:schemeClr val="accent1"/>
-          </a:effectRef>
-          <a:fontRef idx="minor">
-            <a:schemeClr val="tx1"/>
-          </a:fontRef>
-        </p:style>
-      </p:cxnSp>
-      <p:sp>
-        <p:nvSpPr>
-          <p:cNvPr id="20" name="TextBox 19"/>
-          <p:cNvSpPr txBox="1"/>
-          <p:nvPr/>
-        </p:nvSpPr>
-        <p:spPr>
-          <a:xfrm>
-            <a:off x="4216400" y="3479800"/>
-            <a:ext cx="342900" cy="228600"/>
-          </a:xfrm>
-          <a:prstGeom prst="rect">
-            <a:avLst/>
-          </a:prstGeom>
-          <a:noFill/>
-        </p:spPr>
-        <p:txBody>
-          <a:bodyPr wrap="square" lIns="0" rIns="0" tIns="0" bIns="0">
-            <a:spAutoFit/>
-          </a:bodyPr>
-          <a:lstStyle/>
-          <a:p>
-            <a:pPr>
-              <a:lnSpc>
-                <a:spcPct val="118000"/>
-              </a:lnSpc>
-              <a:spcBef>
-                <a:spcPts val="0"/>
-              </a:spcBef>
-              <a:spcAft>
-                <a:spcPts val="0"/>
-              </a:spcAft>
-              <a:defRPr sz="850" b="0">
-                <a:solidFill>
-                  <a:srgbClr val="ACBBB9"/>
-                </a:solidFill>
-                <a:latin typeface="Noto Sans CJK KR"/>
-              </a:defRPr>
-            </a:pPr>
-            <a:r>
-              <a:rPr>
-                <a:ea typeface="Noto Sans CJK KR"/>
-              </a:rPr>
-              <a:t>USB</a:t>
-            </a:r>
-          </a:p>
-        </p:txBody>
-      </p:sp>
-      <p:sp>
-        <p:nvSpPr>
-          <p:cNvPr id="21" name="Rounded Rectangle 20"/>
-          <p:cNvSpPr/>
-          <p:nvPr/>
-        </p:nvSpPr>
-        <p:spPr>
-          <a:xfrm>
-            <a:off x="4533900" y="3289300"/>
-            <a:ext cx="1435100" cy="1066800"/>
-          </a:xfrm>
-          <a:prstGeom prst="roundRect">
-            <a:avLst>
-              <a:gd name="adj" fmla="val 9523"/>
-            </a:avLst>
-          </a:prstGeom>
-          <a:solidFill>
-            <a:srgbClr val="287F89"/>
-          </a:solidFill>
-          <a:ln>
-            <a:noFill/>
-          </a:ln>
-        </p:spPr>
-        <p:style>
-          <a:lnRef idx="1">
-            <a:schemeClr val="accent1"/>
-          </a:lnRef>
-          <a:fillRef idx="3">
-            <a:schemeClr val="accent1"/>
-          </a:fillRef>
-          <a:effectRef idx="2">
-            <a:schemeClr val="accent1"/>
-          </a:effectRef>
-          <a:fontRef idx="minor">
-            <a:schemeClr val="lt1"/>
-          </a:fontRef>
-        </p:style>
-        <p:txBody>
-          <a:bodyPr rtlCol="0" anchor="ctr"/>
-          <a:lstStyle/>
-          <a:p>
-            <a:pPr algn="ctr"/>
-          </a:p>
-        </p:txBody>
-      </p:sp>
-      <p:sp>
-        <p:nvSpPr>
-          <p:cNvPr id="22" name="TextBox 21"/>
-          <p:cNvSpPr txBox="1"/>
-          <p:nvPr/>
-        </p:nvSpPr>
-        <p:spPr>
-          <a:xfrm>
-            <a:off x="4673600" y="3505200"/>
-            <a:ext cx="1155700" cy="368300"/>
-          </a:xfrm>
-          <a:prstGeom prst="rect">
-            <a:avLst/>
-          </a:prstGeom>
-          <a:noFill/>
-        </p:spPr>
-        <p:txBody>
-          <a:bodyPr wrap="square" lIns="0" rIns="0" tIns="0" bIns="0">
-            <a:spAutoFit/>
-          </a:bodyPr>
-          <a:lstStyle/>
-          <a:p>
-            <a:pPr>
-              <a:lnSpc>
-                <a:spcPct val="118000"/>
-              </a:lnSpc>
-              <a:spcBef>
-                <a:spcPts val="0"/>
-              </a:spcBef>
-              <a:spcAft>
-                <a:spcPts val="0"/>
-              </a:spcAft>
-              <a:defRPr sz="1700" b="1">
-                <a:solidFill>
-                  <a:srgbClr val="FFFFFF"/>
-                </a:solidFill>
-                <a:latin typeface="Noto Sans CJK KR"/>
-              </a:defRPr>
-            </a:pPr>
-            <a:r>
-              <a:rPr>
-                <a:ea typeface="Noto Sans CJK KR"/>
-              </a:rPr>
-              <a:t>Android</a:t>
-            </a:r>
-          </a:p>
-        </p:txBody>
-      </p:sp>
-      <p:sp>
-        <p:nvSpPr>
-          <p:cNvPr id="23" name="TextBox 22"/>
-          <p:cNvSpPr txBox="1"/>
-          <p:nvPr/>
-        </p:nvSpPr>
-        <p:spPr>
-          <a:xfrm>
-            <a:off x="4673600" y="3924300"/>
-            <a:ext cx="1155700" cy="279400"/>
-          </a:xfrm>
-          <a:prstGeom prst="rect">
-            <a:avLst/>
-          </a:prstGeom>
-          <a:noFill/>
-        </p:spPr>
-        <p:txBody>
-          <a:bodyPr wrap="square" lIns="0" rIns="0" tIns="0" bIns="0">
-            <a:spAutoFit/>
-          </a:bodyPr>
-          <a:lstStyle/>
-          <a:p>
-            <a:pPr>
-              <a:lnSpc>
-                <a:spcPct val="118000"/>
-              </a:lnSpc>
-              <a:spcBef>
-                <a:spcPts val="0"/>
-              </a:spcBef>
-              <a:spcAft>
-                <a:spcPts val="0"/>
-              </a:spcAft>
-              <a:defRPr sz="1000" b="0">
-                <a:solidFill>
-                  <a:srgbClr val="FFFFFF"/>
-                </a:solidFill>
-                <a:latin typeface="Noto Sans CJK KR"/>
-              </a:defRPr>
-            </a:pPr>
-            <a:r>
-              <a:rPr>
-                <a:ea typeface="Noto Sans CJK KR"/>
-              </a:rPr>
-              <a:t>인식·소리 합성</a:t>
-            </a:r>
-          </a:p>
-        </p:txBody>
-      </p:sp>
-      <p:sp>
-        <p:nvSpPr>
-          <p:cNvPr id="24" name="Rounded Rectangle 23"/>
-          <p:cNvSpPr/>
-          <p:nvPr/>
-        </p:nvSpPr>
-        <p:spPr>
-          <a:xfrm>
-            <a:off x="711200" y="5016500"/>
-            <a:ext cx="5257800" cy="330200"/>
+            <a:off x="711200" y="2895600"/>
+            <a:ext cx="6096000" cy="330200"/>
           </a:xfrm>
           <a:prstGeom prst="roundRect">
             <a:avLst>
@@ -19723,14 +19094,14 @@
       </p:sp>
       <p:sp>
         <p:nvSpPr>
-          <p:cNvPr id="25" name="TextBox 24"/>
+          <p:cNvPr id="11" name="TextBox 10"/>
           <p:cNvSpPr txBox="1"/>
           <p:nvPr/>
         </p:nvSpPr>
         <p:spPr>
           <a:xfrm>
-            <a:off x="838200" y="5067300"/>
-            <a:ext cx="5003800" cy="254000"/>
+            <a:off x="838200" y="2946400"/>
+            <a:ext cx="5842000" cy="254000"/>
           </a:xfrm>
           <a:prstGeom prst="rect">
             <a:avLst/>
@@ -19771,61 +19142,14 @@
       </p:sp>
       <p:sp>
         <p:nvSpPr>
-          <p:cNvPr id="26" name="Rounded Rectangle 25"/>
-          <p:cNvSpPr/>
-          <p:nvPr/>
-        </p:nvSpPr>
-        <p:spPr>
-          <a:xfrm>
-            <a:off x="6261100" y="2667000"/>
-            <a:ext cx="5219700" cy="3149600"/>
-          </a:xfrm>
-          <a:prstGeom prst="roundRect">
-            <a:avLst>
-              <a:gd name="adj" fmla="val 3225"/>
-            </a:avLst>
-          </a:prstGeom>
-          <a:solidFill>
-            <a:srgbClr val="202B30"/>
-          </a:solidFill>
-          <a:ln w="8890">
-            <a:solidFill>
-              <a:srgbClr val="3A474B"/>
-            </a:solidFill>
-          </a:ln>
-        </p:spPr>
-        <p:style>
-          <a:lnRef idx="1">
-            <a:schemeClr val="accent1"/>
-          </a:lnRef>
-          <a:fillRef idx="3">
-            <a:schemeClr val="accent1"/>
-          </a:fillRef>
-          <a:effectRef idx="2">
-            <a:schemeClr val="accent1"/>
-          </a:effectRef>
-          <a:fontRef idx="minor">
-            <a:schemeClr val="lt1"/>
-          </a:fontRef>
-        </p:style>
-        <p:txBody>
-          <a:bodyPr rtlCol="0" anchor="ctr"/>
-          <a:lstStyle/>
-          <a:p>
-            <a:pPr algn="ctr"/>
-          </a:p>
-        </p:txBody>
-      </p:sp>
-      <p:sp>
-        <p:nvSpPr>
-          <p:cNvPr id="27" name="TextBox 26"/>
+          <p:cNvPr id="12" name="TextBox 11"/>
           <p:cNvSpPr txBox="1"/>
           <p:nvPr/>
         </p:nvSpPr>
         <p:spPr>
           <a:xfrm>
-            <a:off x="6464300" y="3886200"/>
-            <a:ext cx="4813300" cy="368300"/>
+            <a:off x="736600" y="3594100"/>
+            <a:ext cx="6096000" cy="812800"/>
           </a:xfrm>
           <a:prstGeom prst="rect">
             <a:avLst/>
@@ -19838,7 +19162,7 @@
           </a:bodyPr>
           <a:lstStyle/>
           <a:p>
-            <a:pPr algn="ctr">
+            <a:pPr>
               <a:lnSpc>
                 <a:spcPct val="118000"/>
               </a:lnSpc>
@@ -19848,7 +19172,7 @@
               <a:spcAft>
                 <a:spcPts val="0"/>
               </a:spcAft>
-              <a:defRPr sz="1600" b="1">
+              <a:defRPr sz="2000" b="0">
                 <a:solidFill>
                   <a:srgbClr val="ACBBB9"/>
                 </a:solidFill>
@@ -19859,21 +19183,93 @@
               <a:rPr>
                 <a:ea typeface="Noto Sans CJK KR"/>
               </a:rPr>
-              <a:t>사진 1 · 테스트용 프로토타입</a:t>
+              <a:t>센서 2개 + Sense 보드·카메라를</a:t>
             </a:r>
           </a:p>
-        </p:txBody>
-      </p:sp>
-      <p:sp>
-        <p:nvSpPr>
-          <p:cNvPr id="28" name="TextBox 27"/>
+          <a:p>
+            <a:pPr>
+              <a:lnSpc>
+                <a:spcPct val="118000"/>
+              </a:lnSpc>
+              <a:spcBef>
+                <a:spcPts val="0"/>
+              </a:spcBef>
+              <a:spcAft>
+                <a:spcPts val="0"/>
+              </a:spcAft>
+              <a:defRPr sz="2000" b="0">
+                <a:solidFill>
+                  <a:srgbClr val="ACBBB9"/>
+                </a:solidFill>
+                <a:latin typeface="Noto Sans CJK KR"/>
+              </a:defRPr>
+            </a:pPr>
+            <a:r>
+              <a:rPr>
+                <a:ea typeface="Noto Sans CJK KR"/>
+              </a:rPr>
+              <a:t>연결해 기능 테스트</a:t>
+            </a:r>
+          </a:p>
+        </p:txBody>
+      </p:sp>
+      <p:sp>
+        <p:nvSpPr>
+          <p:cNvPr id="13" name="Rounded Rectangle 12"/>
+          <p:cNvSpPr/>
+          <p:nvPr/>
+        </p:nvSpPr>
+        <p:spPr>
+          <a:xfrm>
+            <a:off x="711200" y="4838700"/>
+            <a:ext cx="1866899" cy="546100"/>
+          </a:xfrm>
+          <a:prstGeom prst="roundRect">
+            <a:avLst>
+              <a:gd name="adj" fmla="val 18604"/>
+            </a:avLst>
+          </a:prstGeom>
+          <a:solidFill>
+            <a:srgbClr val="202B30"/>
+          </a:solidFill>
+          <a:ln w="8890">
+            <a:solidFill>
+              <a:srgbClr val="3A474B"/>
+            </a:solidFill>
+          </a:ln>
+        </p:spPr>
+        <p:style>
+          <a:lnRef idx="1">
+            <a:schemeClr val="accent1"/>
+          </a:lnRef>
+          <a:fillRef idx="3">
+            <a:schemeClr val="accent1"/>
+          </a:fillRef>
+          <a:effectRef idx="2">
+            <a:schemeClr val="accent1"/>
+          </a:effectRef>
+          <a:fontRef idx="minor">
+            <a:schemeClr val="lt1"/>
+          </a:fontRef>
+        </p:style>
+        <p:txBody>
+          <a:bodyPr rtlCol="0" anchor="ctr"/>
+          <a:lstStyle/>
+          <a:p>
+            <a:pPr algn="ctr"/>
+          </a:p>
+        </p:txBody>
+      </p:sp>
+      <p:sp>
+        <p:nvSpPr>
+          <p:cNvPr id="14" name="TextBox 13"/>
           <p:cNvSpPr txBox="1"/>
           <p:nvPr/>
         </p:nvSpPr>
         <p:spPr>
           <a:xfrm>
-            <a:off x="6464300" y="4381500"/>
-            <a:ext cx="4813300" cy="381000"/>
+            <a:off x="889000" y="4940300"/>
+            <a:ext cx="1511300" cy="330200"/>
           </a:xfrm>
           <a:prstGeom prst="rect">
             <a:avLst/>
@@ -19886,7 +19282,790 @@
           </a:bodyPr>
           <a:lstStyle/>
           <a:p>
+            <a:pPr>
+              <a:lnSpc>
+                <a:spcPct val="118000"/>
+              </a:lnSpc>
+              <a:spcBef>
+                <a:spcPts val="0"/>
+              </a:spcBef>
+              <a:spcAft>
+                <a:spcPts val="0"/>
+              </a:spcAft>
+              <a:defRPr sz="1400" b="1">
+                <a:solidFill>
+                  <a:srgbClr val="FFFFFF"/>
+                </a:solidFill>
+                <a:latin typeface="Noto Sans CJK KR"/>
+              </a:defRPr>
+            </a:pPr>
+            <a:r>
+              <a:rPr>
+                <a:ea typeface="Noto Sans CJK KR"/>
+              </a:rPr>
+              <a:t>A · 왼쪽 L8</a:t>
+            </a:r>
+          </a:p>
+        </p:txBody>
+      </p:sp>
+      <p:sp>
+        <p:nvSpPr>
+          <p:cNvPr id="15" name="Rounded Rectangle 14"/>
+          <p:cNvSpPr/>
+          <p:nvPr/>
+        </p:nvSpPr>
+        <p:spPr>
+          <a:xfrm>
+            <a:off x="711200" y="5613400"/>
+            <a:ext cx="1866899" cy="546100"/>
+          </a:xfrm>
+          <a:prstGeom prst="roundRect">
+            <a:avLst>
+              <a:gd name="adj" fmla="val 18604"/>
+            </a:avLst>
+          </a:prstGeom>
+          <a:solidFill>
+            <a:srgbClr val="202B30"/>
+          </a:solidFill>
+          <a:ln w="8890">
+            <a:solidFill>
+              <a:srgbClr val="3A474B"/>
+            </a:solidFill>
+          </a:ln>
+        </p:spPr>
+        <p:style>
+          <a:lnRef idx="1">
+            <a:schemeClr val="accent1"/>
+          </a:lnRef>
+          <a:fillRef idx="3">
+            <a:schemeClr val="accent1"/>
+          </a:fillRef>
+          <a:effectRef idx="2">
+            <a:schemeClr val="accent1"/>
+          </a:effectRef>
+          <a:fontRef idx="minor">
+            <a:schemeClr val="lt1"/>
+          </a:fontRef>
+        </p:style>
+        <p:txBody>
+          <a:bodyPr rtlCol="0" anchor="ctr"/>
+          <a:lstStyle/>
+          <a:p>
+            <a:pPr algn="ctr"/>
+          </a:p>
+        </p:txBody>
+      </p:sp>
+      <p:sp>
+        <p:nvSpPr>
+          <p:cNvPr id="16" name="TextBox 15"/>
+          <p:cNvSpPr txBox="1"/>
+          <p:nvPr/>
+        </p:nvSpPr>
+        <p:spPr>
+          <a:xfrm>
+            <a:off x="889000" y="5715000"/>
+            <a:ext cx="1511300" cy="330200"/>
+          </a:xfrm>
+          <a:prstGeom prst="rect">
+            <a:avLst/>
+          </a:prstGeom>
+          <a:noFill/>
+        </p:spPr>
+        <p:txBody>
+          <a:bodyPr wrap="square" lIns="0" rIns="0" tIns="0" bIns="0">
+            <a:spAutoFit/>
+          </a:bodyPr>
+          <a:lstStyle/>
+          <a:p>
+            <a:pPr>
+              <a:lnSpc>
+                <a:spcPct val="118000"/>
+              </a:lnSpc>
+              <a:spcBef>
+                <a:spcPts val="0"/>
+              </a:spcBef>
+              <a:spcAft>
+                <a:spcPts val="0"/>
+              </a:spcAft>
+              <a:defRPr sz="1400" b="1">
+                <a:solidFill>
+                  <a:srgbClr val="FFFFFF"/>
+                </a:solidFill>
+                <a:latin typeface="Noto Sans CJK KR"/>
+              </a:defRPr>
+            </a:pPr>
+            <a:r>
+              <a:rPr>
+                <a:ea typeface="Noto Sans CJK KR"/>
+              </a:rPr>
+              <a:t>B · 오른쪽 L8</a:t>
+            </a:r>
+          </a:p>
+        </p:txBody>
+      </p:sp>
+      <p:cxnSp>
+        <p:nvCxnSpPr>
+          <p:cNvPr id="17" name="Connector 16"/>
+          <p:cNvCxnSpPr/>
+          <p:nvPr/>
+        </p:nvCxnSpPr>
+        <p:spPr>
+          <a:xfrm>
+            <a:off x="2578100" y="5105400"/>
+            <a:ext cx="279400" cy="0"/>
+          </a:xfrm>
+          <a:prstGeom prst="line">
+            <a:avLst/>
+          </a:prstGeom>
+          <a:ln w="22860">
+            <a:solidFill>
+              <a:srgbClr val="287F89"/>
+            </a:solidFill>
+          </a:ln>
+        </p:spPr>
+        <p:style>
+          <a:lnRef idx="2">
+            <a:schemeClr val="accent1"/>
+          </a:lnRef>
+          <a:fillRef idx="0">
+            <a:schemeClr val="accent1"/>
+          </a:fillRef>
+          <a:effectRef idx="1">
+            <a:schemeClr val="accent1"/>
+          </a:effectRef>
+          <a:fontRef idx="minor">
+            <a:schemeClr val="tx1"/>
+          </a:fontRef>
+        </p:style>
+      </p:cxnSp>
+      <p:cxnSp>
+        <p:nvCxnSpPr>
+          <p:cNvPr id="18" name="Connector 17"/>
+          <p:cNvCxnSpPr/>
+          <p:nvPr/>
+        </p:nvCxnSpPr>
+        <p:spPr>
+          <a:xfrm>
+            <a:off x="2578100" y="5880100"/>
+            <a:ext cx="279400" cy="0"/>
+          </a:xfrm>
+          <a:prstGeom prst="line">
+            <a:avLst/>
+          </a:prstGeom>
+          <a:ln w="22860">
+            <a:solidFill>
+              <a:srgbClr val="287F89"/>
+            </a:solidFill>
+          </a:ln>
+        </p:spPr>
+        <p:style>
+          <a:lnRef idx="2">
+            <a:schemeClr val="accent1"/>
+          </a:lnRef>
+          <a:fillRef idx="0">
+            <a:schemeClr val="accent1"/>
+          </a:fillRef>
+          <a:effectRef idx="1">
+            <a:schemeClr val="accent1"/>
+          </a:effectRef>
+          <a:fontRef idx="minor">
+            <a:schemeClr val="tx1"/>
+          </a:fontRef>
+        </p:style>
+      </p:cxnSp>
+      <p:cxnSp>
+        <p:nvCxnSpPr>
+          <p:cNvPr id="19" name="Connector 18"/>
+          <p:cNvCxnSpPr/>
+          <p:nvPr/>
+        </p:nvCxnSpPr>
+        <p:spPr>
+          <a:xfrm>
+            <a:off x="2857500" y="5105400"/>
+            <a:ext cx="0" cy="774700"/>
+          </a:xfrm>
+          <a:prstGeom prst="line">
+            <a:avLst/>
+          </a:prstGeom>
+          <a:ln w="22860">
+            <a:solidFill>
+              <a:srgbClr val="287F89"/>
+            </a:solidFill>
+          </a:ln>
+        </p:spPr>
+        <p:style>
+          <a:lnRef idx="2">
+            <a:schemeClr val="accent1"/>
+          </a:lnRef>
+          <a:fillRef idx="0">
+            <a:schemeClr val="accent1"/>
+          </a:fillRef>
+          <a:effectRef idx="1">
+            <a:schemeClr val="accent1"/>
+          </a:effectRef>
+          <a:fontRef idx="minor">
+            <a:schemeClr val="tx1"/>
+          </a:fontRef>
+        </p:style>
+      </p:cxnSp>
+      <p:cxnSp>
+        <p:nvCxnSpPr>
+          <p:cNvPr id="20" name="Connector 19"/>
+          <p:cNvCxnSpPr/>
+          <p:nvPr/>
+        </p:nvCxnSpPr>
+        <p:spPr>
+          <a:xfrm>
+            <a:off x="2857500" y="5486400"/>
+            <a:ext cx="457200" cy="0"/>
+          </a:xfrm>
+          <a:prstGeom prst="line">
+            <a:avLst/>
+          </a:prstGeom>
+          <a:ln w="22860">
+            <a:solidFill>
+              <a:srgbClr val="287F89"/>
+            </a:solidFill>
+            <a:tailEnd type="triangle"/>
+          </a:ln>
+        </p:spPr>
+        <p:style>
+          <a:lnRef idx="2">
+            <a:schemeClr val="accent1"/>
+          </a:lnRef>
+          <a:fillRef idx="0">
+            <a:schemeClr val="accent1"/>
+          </a:fillRef>
+          <a:effectRef idx="1">
+            <a:schemeClr val="accent1"/>
+          </a:effectRef>
+          <a:fontRef idx="minor">
+            <a:schemeClr val="tx1"/>
+          </a:fontRef>
+        </p:style>
+      </p:cxnSp>
+      <p:sp>
+        <p:nvSpPr>
+          <p:cNvPr id="21" name="Rounded Rectangle 20"/>
+          <p:cNvSpPr/>
+          <p:nvPr/>
+        </p:nvSpPr>
+        <p:spPr>
+          <a:xfrm>
+            <a:off x="3365500" y="5016500"/>
+            <a:ext cx="2235200" cy="977900"/>
+          </a:xfrm>
+          <a:prstGeom prst="roundRect">
+            <a:avLst>
+              <a:gd name="adj" fmla="val 10389"/>
+            </a:avLst>
+          </a:prstGeom>
+          <a:solidFill>
+            <a:srgbClr val="202B30"/>
+          </a:solidFill>
+          <a:ln w="8890">
+            <a:solidFill>
+              <a:srgbClr val="3A474B"/>
+            </a:solidFill>
+          </a:ln>
+        </p:spPr>
+        <p:style>
+          <a:lnRef idx="1">
+            <a:schemeClr val="accent1"/>
+          </a:lnRef>
+          <a:fillRef idx="3">
+            <a:schemeClr val="accent1"/>
+          </a:fillRef>
+          <a:effectRef idx="2">
+            <a:schemeClr val="accent1"/>
+          </a:effectRef>
+          <a:fontRef idx="minor">
+            <a:schemeClr val="lt1"/>
+          </a:fontRef>
+        </p:style>
+        <p:txBody>
+          <a:bodyPr rtlCol="0" anchor="ctr"/>
+          <a:lstStyle/>
+          <a:p>
+            <a:pPr algn="ctr"/>
+          </a:p>
+        </p:txBody>
+      </p:sp>
+      <p:sp>
+        <p:nvSpPr>
+          <p:cNvPr id="22" name="TextBox 21"/>
+          <p:cNvSpPr txBox="1"/>
+          <p:nvPr/>
+        </p:nvSpPr>
+        <p:spPr>
+          <a:xfrm>
+            <a:off x="3568700" y="5168900"/>
+            <a:ext cx="1828800" cy="355600"/>
+          </a:xfrm>
+          <a:prstGeom prst="rect">
+            <a:avLst/>
+          </a:prstGeom>
+          <a:noFill/>
+        </p:spPr>
+        <p:txBody>
+          <a:bodyPr wrap="square" lIns="0" rIns="0" tIns="0" bIns="0">
+            <a:spAutoFit/>
+          </a:bodyPr>
+          <a:lstStyle/>
+          <a:p>
+            <a:pPr>
+              <a:lnSpc>
+                <a:spcPct val="118000"/>
+              </a:lnSpc>
+              <a:spcBef>
+                <a:spcPts val="0"/>
+              </a:spcBef>
+              <a:spcAft>
+                <a:spcPts val="0"/>
+              </a:spcAft>
+              <a:defRPr sz="1700" b="1">
+                <a:solidFill>
+                  <a:srgbClr val="FFFFFF"/>
+                </a:solidFill>
+                <a:latin typeface="Noto Sans CJK KR"/>
+              </a:defRPr>
+            </a:pPr>
+            <a:r>
+              <a:rPr>
+                <a:ea typeface="Noto Sans CJK KR"/>
+              </a:rPr>
+              <a:t>XIAO ESP32-S3</a:t>
+            </a:r>
+          </a:p>
+        </p:txBody>
+      </p:sp>
+      <p:sp>
+        <p:nvSpPr>
+          <p:cNvPr id="23" name="TextBox 22"/>
+          <p:cNvSpPr txBox="1"/>
+          <p:nvPr/>
+        </p:nvSpPr>
+        <p:spPr>
+          <a:xfrm>
+            <a:off x="3568700" y="5588000"/>
+            <a:ext cx="1828800" cy="292100"/>
+          </a:xfrm>
+          <a:prstGeom prst="rect">
+            <a:avLst/>
+          </a:prstGeom>
+          <a:noFill/>
+        </p:spPr>
+        <p:txBody>
+          <a:bodyPr wrap="square" lIns="0" rIns="0" tIns="0" bIns="0">
+            <a:spAutoFit/>
+          </a:bodyPr>
+          <a:lstStyle/>
+          <a:p>
+            <a:pPr>
+              <a:lnSpc>
+                <a:spcPct val="118000"/>
+              </a:lnSpc>
+              <a:spcBef>
+                <a:spcPts val="0"/>
+              </a:spcBef>
+              <a:spcAft>
+                <a:spcPts val="0"/>
+              </a:spcAft>
+              <a:defRPr sz="1050" b="0">
+                <a:solidFill>
+                  <a:srgbClr val="ACBBB9"/>
+                </a:solidFill>
+                <a:latin typeface="Noto Sans CJK KR"/>
+              </a:defRPr>
+            </a:pPr>
+            <a:r>
+              <a:rPr>
+                <a:ea typeface="Noto Sans CJK KR"/>
+              </a:rPr>
+              <a:t>센서·카메라 데이터 수집</a:t>
+            </a:r>
+          </a:p>
+        </p:txBody>
+      </p:sp>
+      <p:cxnSp>
+        <p:nvCxnSpPr>
+          <p:cNvPr id="24" name="Connector 23"/>
+          <p:cNvCxnSpPr/>
+          <p:nvPr/>
+        </p:nvCxnSpPr>
+        <p:spPr>
+          <a:xfrm>
+            <a:off x="5600700" y="5486400"/>
+            <a:ext cx="571500" cy="0"/>
+          </a:xfrm>
+          <a:prstGeom prst="line">
+            <a:avLst/>
+          </a:prstGeom>
+          <a:ln w="22860">
+            <a:solidFill>
+              <a:srgbClr val="287F89"/>
+            </a:solidFill>
+            <a:tailEnd type="triangle"/>
+          </a:ln>
+        </p:spPr>
+        <p:style>
+          <a:lnRef idx="2">
+            <a:schemeClr val="accent1"/>
+          </a:lnRef>
+          <a:fillRef idx="0">
+            <a:schemeClr val="accent1"/>
+          </a:fillRef>
+          <a:effectRef idx="1">
+            <a:schemeClr val="accent1"/>
+          </a:effectRef>
+          <a:fontRef idx="minor">
+            <a:schemeClr val="tx1"/>
+          </a:fontRef>
+        </p:style>
+      </p:cxnSp>
+      <p:sp>
+        <p:nvSpPr>
+          <p:cNvPr id="25" name="TextBox 24"/>
+          <p:cNvSpPr txBox="1"/>
+          <p:nvPr/>
+        </p:nvSpPr>
+        <p:spPr>
+          <a:xfrm>
+            <a:off x="5676900" y="5130800"/>
+            <a:ext cx="431800" cy="266700"/>
+          </a:xfrm>
+          <a:prstGeom prst="rect">
+            <a:avLst/>
+          </a:prstGeom>
+          <a:noFill/>
+        </p:spPr>
+        <p:txBody>
+          <a:bodyPr wrap="square" lIns="0" rIns="0" tIns="0" bIns="0">
+            <a:spAutoFit/>
+          </a:bodyPr>
+          <a:lstStyle/>
+          <a:p>
             <a:pPr algn="ctr">
+              <a:lnSpc>
+                <a:spcPct val="118000"/>
+              </a:lnSpc>
+              <a:spcBef>
+                <a:spcPts val="0"/>
+              </a:spcBef>
+              <a:spcAft>
+                <a:spcPts val="0"/>
+              </a:spcAft>
+              <a:defRPr sz="1000" b="0">
+                <a:solidFill>
+                  <a:srgbClr val="ACBBB9"/>
+                </a:solidFill>
+                <a:latin typeface="Noto Sans CJK KR"/>
+              </a:defRPr>
+            </a:pPr>
+            <a:r>
+              <a:rPr>
+                <a:ea typeface="Noto Sans CJK KR"/>
+              </a:rPr>
+              <a:t>USB</a:t>
+            </a:r>
+          </a:p>
+        </p:txBody>
+      </p:sp>
+      <p:sp>
+        <p:nvSpPr>
+          <p:cNvPr id="26" name="Rounded Rectangle 25"/>
+          <p:cNvSpPr/>
+          <p:nvPr/>
+        </p:nvSpPr>
+        <p:spPr>
+          <a:xfrm>
+            <a:off x="6223000" y="5016500"/>
+            <a:ext cx="2209800" cy="977900"/>
+          </a:xfrm>
+          <a:prstGeom prst="roundRect">
+            <a:avLst>
+              <a:gd name="adj" fmla="val 10389"/>
+            </a:avLst>
+          </a:prstGeom>
+          <a:solidFill>
+            <a:srgbClr val="287F89"/>
+          </a:solidFill>
+          <a:ln>
+            <a:noFill/>
+          </a:ln>
+        </p:spPr>
+        <p:style>
+          <a:lnRef idx="1">
+            <a:schemeClr val="accent1"/>
+          </a:lnRef>
+          <a:fillRef idx="3">
+            <a:schemeClr val="accent1"/>
+          </a:fillRef>
+          <a:effectRef idx="2">
+            <a:schemeClr val="accent1"/>
+          </a:effectRef>
+          <a:fontRef idx="minor">
+            <a:schemeClr val="lt1"/>
+          </a:fontRef>
+        </p:style>
+        <p:txBody>
+          <a:bodyPr rtlCol="0" anchor="ctr"/>
+          <a:lstStyle/>
+          <a:p>
+            <a:pPr algn="ctr"/>
+          </a:p>
+        </p:txBody>
+      </p:sp>
+      <p:sp>
+        <p:nvSpPr>
+          <p:cNvPr id="27" name="TextBox 26"/>
+          <p:cNvSpPr txBox="1"/>
+          <p:nvPr/>
+        </p:nvSpPr>
+        <p:spPr>
+          <a:xfrm>
+            <a:off x="6438900" y="5181600"/>
+            <a:ext cx="1778000" cy="355600"/>
+          </a:xfrm>
+          <a:prstGeom prst="rect">
+            <a:avLst/>
+          </a:prstGeom>
+          <a:noFill/>
+        </p:spPr>
+        <p:txBody>
+          <a:bodyPr wrap="square" lIns="0" rIns="0" tIns="0" bIns="0">
+            <a:spAutoFit/>
+          </a:bodyPr>
+          <a:lstStyle/>
+          <a:p>
+            <a:pPr>
+              <a:lnSpc>
+                <a:spcPct val="118000"/>
+              </a:lnSpc>
+              <a:spcBef>
+                <a:spcPts val="0"/>
+              </a:spcBef>
+              <a:spcAft>
+                <a:spcPts val="0"/>
+              </a:spcAft>
+              <a:defRPr sz="2000" b="1">
+                <a:solidFill>
+                  <a:srgbClr val="FFFFFF"/>
+                </a:solidFill>
+                <a:latin typeface="Noto Sans CJK KR"/>
+              </a:defRPr>
+            </a:pPr>
+            <a:r>
+              <a:rPr>
+                <a:ea typeface="Noto Sans CJK KR"/>
+              </a:rPr>
+              <a:t>Android 앱</a:t>
+            </a:r>
+          </a:p>
+        </p:txBody>
+      </p:sp>
+      <p:sp>
+        <p:nvSpPr>
+          <p:cNvPr id="28" name="TextBox 27"/>
+          <p:cNvSpPr txBox="1"/>
+          <p:nvPr/>
+        </p:nvSpPr>
+        <p:spPr>
+          <a:xfrm>
+            <a:off x="6438900" y="5626100"/>
+            <a:ext cx="1778000" cy="292100"/>
+          </a:xfrm>
+          <a:prstGeom prst="rect">
+            <a:avLst/>
+          </a:prstGeom>
+          <a:noFill/>
+        </p:spPr>
+        <p:txBody>
+          <a:bodyPr wrap="square" lIns="0" rIns="0" tIns="0" bIns="0">
+            <a:spAutoFit/>
+          </a:bodyPr>
+          <a:lstStyle/>
+          <a:p>
+            <a:pPr>
+              <a:lnSpc>
+                <a:spcPct val="118000"/>
+              </a:lnSpc>
+              <a:spcBef>
+                <a:spcPts val="0"/>
+              </a:spcBef>
+              <a:spcAft>
+                <a:spcPts val="0"/>
+              </a:spcAft>
+              <a:defRPr sz="1100" b="0">
+                <a:solidFill>
+                  <a:srgbClr val="FFFFFF"/>
+                </a:solidFill>
+                <a:latin typeface="Noto Sans CJK KR"/>
+              </a:defRPr>
+            </a:pPr>
+            <a:r>
+              <a:rPr>
+                <a:ea typeface="Noto Sans CJK KR"/>
+              </a:rPr>
+              <a:t>객체 인식 · 소리 합성</a:t>
+            </a:r>
+          </a:p>
+        </p:txBody>
+      </p:sp>
+      <p:cxnSp>
+        <p:nvCxnSpPr>
+          <p:cNvPr id="29" name="Connector 28"/>
+          <p:cNvCxnSpPr/>
+          <p:nvPr/>
+        </p:nvCxnSpPr>
+        <p:spPr>
+          <a:xfrm>
+            <a:off x="8432800" y="5486400"/>
+            <a:ext cx="609600" cy="0"/>
+          </a:xfrm>
+          <a:prstGeom prst="line">
+            <a:avLst/>
+          </a:prstGeom>
+          <a:ln w="22860">
+            <a:solidFill>
+              <a:srgbClr val="287F89"/>
+            </a:solidFill>
+            <a:tailEnd type="triangle"/>
+          </a:ln>
+        </p:spPr>
+        <p:style>
+          <a:lnRef idx="2">
+            <a:schemeClr val="accent1"/>
+          </a:lnRef>
+          <a:fillRef idx="0">
+            <a:schemeClr val="accent1"/>
+          </a:fillRef>
+          <a:effectRef idx="1">
+            <a:schemeClr val="accent1"/>
+          </a:effectRef>
+          <a:fontRef idx="minor">
+            <a:schemeClr val="tx1"/>
+          </a:fontRef>
+        </p:style>
+      </p:cxnSp>
+      <p:sp>
+        <p:nvSpPr>
+          <p:cNvPr id="30" name="Rounded Rectangle 29"/>
+          <p:cNvSpPr/>
+          <p:nvPr/>
+        </p:nvSpPr>
+        <p:spPr>
+          <a:xfrm>
+            <a:off x="9093200" y="5016500"/>
+            <a:ext cx="2387600" cy="977900"/>
+          </a:xfrm>
+          <a:prstGeom prst="roundRect">
+            <a:avLst>
+              <a:gd name="adj" fmla="val 10389"/>
+            </a:avLst>
+          </a:prstGeom>
+          <a:solidFill>
+            <a:srgbClr val="202B30"/>
+          </a:solidFill>
+          <a:ln w="8890">
+            <a:solidFill>
+              <a:srgbClr val="3A474B"/>
+            </a:solidFill>
+          </a:ln>
+        </p:spPr>
+        <p:style>
+          <a:lnRef idx="1">
+            <a:schemeClr val="accent1"/>
+          </a:lnRef>
+          <a:fillRef idx="3">
+            <a:schemeClr val="accent1"/>
+          </a:fillRef>
+          <a:effectRef idx="2">
+            <a:schemeClr val="accent1"/>
+          </a:effectRef>
+          <a:fontRef idx="minor">
+            <a:schemeClr val="lt1"/>
+          </a:fontRef>
+        </p:style>
+        <p:txBody>
+          <a:bodyPr rtlCol="0" anchor="ctr"/>
+          <a:lstStyle/>
+          <a:p>
+            <a:pPr algn="ctr"/>
+          </a:p>
+        </p:txBody>
+      </p:sp>
+      <p:sp>
+        <p:nvSpPr>
+          <p:cNvPr id="31" name="TextBox 30"/>
+          <p:cNvSpPr txBox="1"/>
+          <p:nvPr/>
+        </p:nvSpPr>
+        <p:spPr>
+          <a:xfrm>
+            <a:off x="9296400" y="5181600"/>
+            <a:ext cx="1981199" cy="368300"/>
+          </a:xfrm>
+          <a:prstGeom prst="rect">
+            <a:avLst/>
+          </a:prstGeom>
+          <a:noFill/>
+        </p:spPr>
+        <p:txBody>
+          <a:bodyPr wrap="square" lIns="0" rIns="0" tIns="0" bIns="0">
+            <a:spAutoFit/>
+          </a:bodyPr>
+          <a:lstStyle/>
+          <a:p>
+            <a:pPr>
+              <a:lnSpc>
+                <a:spcPct val="118000"/>
+              </a:lnSpc>
+              <a:spcBef>
+                <a:spcPts val="0"/>
+              </a:spcBef>
+              <a:spcAft>
+                <a:spcPts val="0"/>
+              </a:spcAft>
+              <a:defRPr sz="1800" b="1">
+                <a:solidFill>
+                  <a:srgbClr val="FFFFFF"/>
+                </a:solidFill>
+                <a:latin typeface="Noto Sans CJK KR"/>
+              </a:defRPr>
+            </a:pPr>
+            <a:r>
+              <a:rPr>
+                <a:ea typeface="Noto Sans CJK KR"/>
+              </a:rPr>
+              <a:t>스테레오 이어폰</a:t>
+            </a:r>
+          </a:p>
+        </p:txBody>
+      </p:sp>
+      <p:sp>
+        <p:nvSpPr>
+          <p:cNvPr id="32" name="TextBox 31"/>
+          <p:cNvSpPr txBox="1"/>
+          <p:nvPr/>
+        </p:nvSpPr>
+        <p:spPr>
+          <a:xfrm>
+            <a:off x="9296400" y="5626100"/>
+            <a:ext cx="1981199" cy="292100"/>
+          </a:xfrm>
+          <a:prstGeom prst="rect">
+            <a:avLst/>
+          </a:prstGeom>
+          <a:noFill/>
+        </p:spPr>
+        <p:txBody>
+          <a:bodyPr wrap="square" lIns="0" rIns="0" tIns="0" bIns="0">
+            <a:spAutoFit/>
+          </a:bodyPr>
+          <a:lstStyle/>
+          <a:p>
+            <a:pPr>
               <a:lnSpc>
                 <a:spcPct val="118000"/>
               </a:lnSpc>
@@ -19907,55 +20086,7 @@
               <a:rPr>
                 <a:ea typeface="Noto Sans CJK KR"/>
               </a:rPr>
-              <a:t>원본 파일 수신 후 삽입</a:t>
-            </a:r>
-          </a:p>
-        </p:txBody>
-      </p:sp>
-      <p:sp>
-        <p:nvSpPr>
-          <p:cNvPr id="29" name="TextBox 28"/>
-          <p:cNvSpPr txBox="1"/>
-          <p:nvPr/>
-        </p:nvSpPr>
-        <p:spPr>
-          <a:xfrm>
-            <a:off x="6286500" y="5930900"/>
-            <a:ext cx="5168900" cy="304800"/>
-          </a:xfrm>
-          <a:prstGeom prst="rect">
-            <a:avLst/>
-          </a:prstGeom>
-          <a:noFill/>
-        </p:spPr>
-        <p:txBody>
-          <a:bodyPr wrap="square" lIns="0" rIns="0" tIns="0" bIns="0">
-            <a:spAutoFit/>
-          </a:bodyPr>
-          <a:lstStyle/>
-          <a:p>
-            <a:pPr>
-              <a:lnSpc>
-                <a:spcPct val="118000"/>
-              </a:lnSpc>
-              <a:spcBef>
-                <a:spcPts val="0"/>
-              </a:spcBef>
-              <a:spcAft>
-                <a:spcPts val="0"/>
-              </a:spcAft>
-              <a:defRPr sz="1100" b="0">
-                <a:solidFill>
-                  <a:srgbClr val="ACBBB9"/>
-                </a:solidFill>
-                <a:latin typeface="Noto Sans CJK KR"/>
-              </a:defRPr>
-            </a:pPr>
-            <a:r>
-              <a:rPr>
-                <a:ea typeface="Noto Sans CJK KR"/>
-              </a:rPr>
-              <a:t>센서 2개 + Sense 보드·카메라를 연결해 기능 테스트</a:t>
+              <a:t>거리·방향음 출력</a:t>
             </a:r>
           </a:p>
         </p:txBody>

</xml_diff>